<commit_message>
feat: add academy page-specific ogp assets
- OGP Master Template に Slide 11(community-apply)/12(premium-apply) を追加
  （既存 Slide 06/07 を複製しタイトル・サブコピーのみ差し替え。背景・ロゴ・配色は不変）
- generated/community-apply.png / premium-apply.png を 1200x630 で出力（Master から再生成）
- community-apply.html / premium-apply.html の og:image を専用画像へ更新
  （従来は汎用 apply.png を流用していた）
- LibreOffice レンダリングが既存 PNG とピクセル一致することを確認して生成
- assets/ogp/README.md 更新（Slide 11/12・コピー一覧・HTML対応表・og専用運用の注記）
- docs/academy-ogp-operation.md 新規（Master 選定根拠・生成/出力/反映/検証手順）

Co-Authored-By: Claude Opus 4.8 <noreply@anthropic.com>
</commit_message>
<xml_diff>
--- a/assets/ogp/master/OGP_Template_Master.pptx
+++ b/assets/ogp/master/OGP_Template_Master.pptx
@@ -15,6 +15,8 @@
     <p:sldId id="263" r:id="rId9"/>
     <p:sldId id="264" r:id="rId10"/>
     <p:sldId id="265" r:id="rId11"/>
+    <p:sldId id="266" r:id="rId17"/>
+    <p:sldId id="267" r:id="rId18"/>
   </p:sldIdLst>
   <p:notesMasterIdLst>
     <p:notesMasterId r:id="rId12"/>
@@ -2455,6 +2457,302 @@
 </p:sld>
 </file>
 
+<file path=ppt/slides/slide11.xml><?xml version="1.0" encoding="utf-8"?>
+<p:sld xmlns:a="http://schemas.openxmlformats.org/drawingml/2006/main" xmlns:r="http://schemas.openxmlformats.org/officeDocument/2006/relationships" xmlns:p="http://schemas.openxmlformats.org/presentationml/2006/main">
+  <p:cSld name="community">
+    <p:spTree>
+      <p:nvGrpSpPr>
+        <p:cNvPr id="1" name=""/>
+        <p:cNvGrpSpPr/>
+        <p:nvPr/>
+      </p:nvGrpSpPr>
+      <p:grpSpPr>
+        <a:xfrm>
+          <a:off x="0" y="0"/>
+          <a:ext cx="0" cy="0"/>
+          <a:chOff x="0" y="0"/>
+          <a:chExt cx="0" cy="0"/>
+        </a:xfrm>
+      </p:grpSpPr>
+      <p:sp>
+        <p:nvSpPr>
+          <p:cNvPr id="2" name="Text 5"/>
+          <p:cNvSpPr/>
+          <p:nvPr>
+            <p:ph idx="105" type="body" hasCustomPrompt="1"/>
+          </p:nvPr>
+        </p:nvSpPr>
+        <p:spPr>
+          <a:xfrm>
+            <a:off x="857250" y="1677924"/>
+            <a:ext cx="9715500" cy="256032"/>
+          </a:xfrm>
+          <a:prstGeom prst="rect">
+            <a:avLst/>
+          </a:prstGeom>
+          <a:noFill/>
+          <a:ln/>
+        </p:spPr>
+        <p:txBody>
+          <a:bodyPr wrap="square" lIns="0" tIns="0" rIns="0" bIns="0" rtlCol="0" anchor="ctr"/>
+          <a:lstStyle/>
+          <a:p>
+            <a:pPr algn="ctr" indent="0" marL="0">
+              <a:buNone/>
+            </a:pPr>
+            <a:r>
+              <a:rPr lang="en-US" sz="1200" spc="250" kern="0" dirty="0">
+                <a:solidFill>
+                  <a:srgbClr val="C0B8AD"/>
+                </a:solidFill>
+                <a:latin typeface="Noto Sans JP" pitchFamily="34" charset="0"/>
+                <a:ea typeface="Noto Sans JP" pitchFamily="34" charset="-122"/>
+                <a:cs typeface="Noto Sans JP" pitchFamily="34" charset="-120"/>
+              </a:rPr>
+              <a:t>DREAMIN' SPIRAL ACADEMY</a:t>
+            </a:r>
+            <a:endParaRPr lang="en-US" sz="1200" dirty="0"/>
+          </a:p>
+        </p:txBody>
+      </p:sp>
+      <p:sp>
+        <p:nvSpPr>
+          <p:cNvPr id="3" name="Text 5"/>
+          <p:cNvSpPr/>
+          <p:nvPr>
+            <p:ph idx="106" type="title" hasCustomPrompt="1"/>
+          </p:nvPr>
+        </p:nvSpPr>
+        <p:spPr>
+          <a:xfrm>
+            <a:off x="857250" y="2467356"/>
+            <a:ext cx="9715500" cy="960120"/>
+          </a:xfrm>
+          <a:prstGeom prst="rect">
+            <a:avLst/>
+          </a:prstGeom>
+          <a:noFill/>
+          <a:ln/>
+        </p:spPr>
+        <p:txBody>
+          <a:bodyPr wrap="square" lIns="0" tIns="0" rIns="0" bIns="0" rtlCol="0" anchor="ctr"/>
+          <a:lstStyle/>
+          <a:p>
+            <a:pPr algn="ctr" indent="0" marL="0">
+              <a:buNone/>
+            </a:pPr>
+            <a:r>
+              <a:rPr lang="en-US" sz="6600" dirty="0">
+                <a:solidFill>
+                  <a:srgbClr val="F7F6F4"/>
+                </a:solidFill>
+                <a:latin typeface="Noto Sans JP" pitchFamily="34" charset="0"/>
+                <a:ea typeface="Noto Sans JP" pitchFamily="34" charset="-122"/>
+                <a:cs typeface="Noto Sans JP" pitchFamily="34" charset="-120"/>
+              </a:rPr>
+              <a:t>Community に参加する</a:t>
+            </a:r>
+            <a:endParaRPr lang="en-US" sz="6600" dirty="0"/>
+          </a:p>
+        </p:txBody>
+      </p:sp>
+      <p:sp>
+        <p:nvSpPr>
+          <p:cNvPr id="4" name="Text 5"/>
+          <p:cNvSpPr/>
+          <p:nvPr>
+            <p:ph idx="107" type="body" hasCustomPrompt="1"/>
+          </p:nvPr>
+        </p:nvSpPr>
+        <p:spPr>
+          <a:xfrm>
+            <a:off x="857250" y="3732276"/>
+            <a:ext cx="9715500" cy="411480"/>
+          </a:xfrm>
+          <a:prstGeom prst="rect">
+            <a:avLst/>
+          </a:prstGeom>
+          <a:noFill/>
+          <a:ln/>
+        </p:spPr>
+        <p:txBody>
+          <a:bodyPr wrap="square" lIns="0" tIns="0" rIns="0" bIns="0" rtlCol="0" anchor="ctr"/>
+          <a:lstStyle/>
+          <a:p>
+            <a:pPr algn="ctr" indent="0" marL="0">
+              <a:buNone/>
+            </a:pPr>
+            <a:r>
+              <a:rPr lang="en-US" sz="2250" dirty="0">
+                <a:solidFill>
+                  <a:srgbClr val="A8A49E"/>
+                </a:solidFill>
+                <a:latin typeface="Noto Sans JP" pitchFamily="34" charset="0"/>
+                <a:ea typeface="Noto Sans JP" pitchFamily="34" charset="-122"/>
+                <a:cs typeface="Noto Sans JP" pitchFamily="34" charset="-120"/>
+              </a:rPr>
+              <a:t>共に育つ場へ。</a:t>
+            </a:r>
+            <a:endParaRPr lang="en-US" sz="2250" dirty="0"/>
+          </a:p>
+        </p:txBody>
+      </p:sp>
+    </p:spTree>
+  </p:cSld>
+  <p:clrMapOvr>
+    <a:masterClrMapping/>
+  </p:clrMapOvr>
+</p:sld>
+</file>
+
+<file path=ppt/slides/slide12.xml><?xml version="1.0" encoding="utf-8"?>
+<p:sld xmlns:a="http://schemas.openxmlformats.org/drawingml/2006/main" xmlns:r="http://schemas.openxmlformats.org/officeDocument/2006/relationships" xmlns:p="http://schemas.openxmlformats.org/presentationml/2006/main">
+  <p:cSld name="premium">
+    <p:spTree>
+      <p:nvGrpSpPr>
+        <p:cNvPr id="1" name=""/>
+        <p:cNvGrpSpPr/>
+        <p:nvPr/>
+      </p:nvGrpSpPr>
+      <p:grpSpPr>
+        <a:xfrm>
+          <a:off x="0" y="0"/>
+          <a:ext cx="0" cy="0"/>
+          <a:chOff x="0" y="0"/>
+          <a:chExt cx="0" cy="0"/>
+        </a:xfrm>
+      </p:grpSpPr>
+      <p:sp>
+        <p:nvSpPr>
+          <p:cNvPr id="2" name="Text 5"/>
+          <p:cNvSpPr/>
+          <p:nvPr>
+            <p:ph idx="105" type="body" hasCustomPrompt="1"/>
+          </p:nvPr>
+        </p:nvSpPr>
+        <p:spPr>
+          <a:xfrm>
+            <a:off x="857250" y="1677924"/>
+            <a:ext cx="9715500" cy="256032"/>
+          </a:xfrm>
+          <a:prstGeom prst="rect">
+            <a:avLst/>
+          </a:prstGeom>
+          <a:noFill/>
+          <a:ln/>
+        </p:spPr>
+        <p:txBody>
+          <a:bodyPr wrap="square" lIns="0" tIns="0" rIns="0" bIns="0" rtlCol="0" anchor="ctr"/>
+          <a:lstStyle/>
+          <a:p>
+            <a:pPr algn="ctr" indent="0" marL="0">
+              <a:buNone/>
+            </a:pPr>
+            <a:r>
+              <a:rPr lang="en-US" sz="1200" spc="250" kern="0" dirty="0">
+                <a:solidFill>
+                  <a:srgbClr val="C0B8AD"/>
+                </a:solidFill>
+                <a:latin typeface="Noto Sans JP" pitchFamily="34" charset="0"/>
+                <a:ea typeface="Noto Sans JP" pitchFamily="34" charset="-122"/>
+                <a:cs typeface="Noto Sans JP" pitchFamily="34" charset="-120"/>
+              </a:rPr>
+              <a:t>DREAMIN' SPIRAL ACADEMY</a:t>
+            </a:r>
+            <a:endParaRPr lang="en-US" sz="1200" dirty="0"/>
+          </a:p>
+        </p:txBody>
+      </p:sp>
+      <p:sp>
+        <p:nvSpPr>
+          <p:cNvPr id="3" name="Text 5"/>
+          <p:cNvSpPr/>
+          <p:nvPr>
+            <p:ph idx="106" type="title" hasCustomPrompt="1"/>
+          </p:nvPr>
+        </p:nvSpPr>
+        <p:spPr>
+          <a:xfrm>
+            <a:off x="857250" y="2467356"/>
+            <a:ext cx="9715500" cy="960120"/>
+          </a:xfrm>
+          <a:prstGeom prst="rect">
+            <a:avLst/>
+          </a:prstGeom>
+          <a:noFill/>
+          <a:ln/>
+        </p:spPr>
+        <p:txBody>
+          <a:bodyPr wrap="square" lIns="0" tIns="0" rIns="0" bIns="0" rtlCol="0" anchor="ctr"/>
+          <a:lstStyle/>
+          <a:p>
+            <a:pPr algn="ctr" indent="0" marL="0">
+              <a:buNone/>
+            </a:pPr>
+            <a:r>
+              <a:rPr lang="en-US" sz="6600" dirty="0">
+                <a:solidFill>
+                  <a:srgbClr val="F7F6F4"/>
+                </a:solidFill>
+                <a:latin typeface="Noto Sans JP" pitchFamily="34" charset="0"/>
+                <a:ea typeface="Noto Sans JP" pitchFamily="34" charset="-122"/>
+                <a:cs typeface="Noto Sans JP" pitchFamily="34" charset="-120"/>
+              </a:rPr>
+              <a:t>Premium 伴走を始める</a:t>
+            </a:r>
+            <a:endParaRPr lang="en-US" sz="6600" dirty="0"/>
+          </a:p>
+        </p:txBody>
+      </p:sp>
+      <p:sp>
+        <p:nvSpPr>
+          <p:cNvPr id="4" name="Text 5"/>
+          <p:cNvSpPr/>
+          <p:nvPr>
+            <p:ph idx="107" type="body" hasCustomPrompt="1"/>
+          </p:nvPr>
+        </p:nvSpPr>
+        <p:spPr>
+          <a:xfrm>
+            <a:off x="857250" y="3732276"/>
+            <a:ext cx="9715500" cy="411480"/>
+          </a:xfrm>
+          <a:prstGeom prst="rect">
+            <a:avLst/>
+          </a:prstGeom>
+          <a:noFill/>
+          <a:ln/>
+        </p:spPr>
+        <p:txBody>
+          <a:bodyPr wrap="square" lIns="0" tIns="0" rIns="0" bIns="0" rtlCol="0" anchor="ctr"/>
+          <a:lstStyle/>
+          <a:p>
+            <a:pPr algn="ctr" indent="0" marL="0">
+              <a:buNone/>
+            </a:pPr>
+            <a:r>
+              <a:rPr lang="en-US" sz="2250" dirty="0">
+                <a:solidFill>
+                  <a:srgbClr val="A8A49E"/>
+                </a:solidFill>
+                <a:latin typeface="Noto Sans JP" pitchFamily="34" charset="0"/>
+                <a:ea typeface="Noto Sans JP" pitchFamily="34" charset="-122"/>
+                <a:cs typeface="Noto Sans JP" pitchFamily="34" charset="-120"/>
+              </a:rPr>
+              <a:t>個別の伴走を、始める。</a:t>
+            </a:r>
+            <a:endParaRPr lang="en-US" sz="2250" dirty="0"/>
+          </a:p>
+        </p:txBody>
+      </p:sp>
+    </p:spTree>
+  </p:cSld>
+  <p:clrMapOvr>
+    <a:masterClrMapping/>
+  </p:clrMapOvr>
+</p:sld>
+</file>
+
 <file path=ppt/slides/slide2.xml><?xml version="1.0" encoding="utf-8"?>
 <p:sld xmlns:a="http://schemas.openxmlformats.org/drawingml/2006/main" xmlns:r="http://schemas.openxmlformats.org/officeDocument/2006/relationships" xmlns:p="http://schemas.openxmlformats.org/presentationml/2006/main">
   <p:cSld name="top">

</xml_diff>